<commit_message>
Add source notes to generated training deck
</commit_message>
<xml_diff>
--- a/deliverables/jays-greenhouse-training.pptx
+++ b/deliverables/jays-greenhouse-training.pptx
@@ -2,17 +2,17 @@
 <file path=ppt/presentation.xml><?xml version="1.0" encoding="utf-8"?>
 <p:presentation xmlns:p="http://schemas.openxmlformats.org/presentationml/2006/main">
   <p:sldMasterIdLst>
-    <p:sldMasterId xmlns:r="http://schemas.openxmlformats.org/officeDocument/2006/relationships" id="2147483648" r:id="R7523084d4d424217"/>
+    <p:sldMasterId xmlns:r="http://schemas.openxmlformats.org/officeDocument/2006/relationships" id="2147483648" r:id="Rea039871e5234c96"/>
   </p:sldMasterIdLst>
   <p:notesMasterIdLst>
-    <p:notesMasterId xmlns:r="http://schemas.openxmlformats.org/officeDocument/2006/relationships" r:id="R93e724f9ecaf4251"/>
+    <p:notesMasterId xmlns:r="http://schemas.openxmlformats.org/officeDocument/2006/relationships" r:id="R73e891f1787446f1"/>
   </p:notesMasterIdLst>
   <p:sldIdLst>
-    <p:sldId xmlns:r="http://schemas.openxmlformats.org/officeDocument/2006/relationships" id="256" r:id="R31624f7e235342db"/>
-    <p:sldId xmlns:r="http://schemas.openxmlformats.org/officeDocument/2006/relationships" id="257" r:id="R51b6a7561bea4a4c"/>
-    <p:sldId xmlns:r="http://schemas.openxmlformats.org/officeDocument/2006/relationships" id="258" r:id="R885a7e730bdc4383"/>
-    <p:sldId xmlns:r="http://schemas.openxmlformats.org/officeDocument/2006/relationships" id="259" r:id="Ra3cbffa930c64d1c"/>
-    <p:sldId xmlns:r="http://schemas.openxmlformats.org/officeDocument/2006/relationships" id="260" r:id="R5f046789154547f2"/>
+    <p:sldId xmlns:r="http://schemas.openxmlformats.org/officeDocument/2006/relationships" id="256" r:id="Rccd37be3cf3a4f19"/>
+    <p:sldId xmlns:r="http://schemas.openxmlformats.org/officeDocument/2006/relationships" id="257" r:id="Rd58cbda1606f446e"/>
+    <p:sldId xmlns:r="http://schemas.openxmlformats.org/officeDocument/2006/relationships" id="258" r:id="Ra241299281ce41eb"/>
+    <p:sldId xmlns:r="http://schemas.openxmlformats.org/officeDocument/2006/relationships" id="259" r:id="Rf8bccc89a13a40d4"/>
+    <p:sldId xmlns:r="http://schemas.openxmlformats.org/officeDocument/2006/relationships" id="260" r:id="R7acdfa437a5a46cc"/>
   </p:sldIdLst>
   <p:sldSz cx="12192000" cy="6858000"/>
   <p:notesSz cx="6858000" cy="9144000"/>
@@ -444,7 +444,16 @@
         <p:txBody>
           <a:bodyPr xmlns:a="http://schemas.openxmlformats.org/drawingml/2006/main"/>
           <a:lstStyle xmlns:a="http://schemas.openxmlformats.org/drawingml/2006/main"/>
-          <a:p xmlns:a="http://schemas.openxmlformats.org/drawingml/2006/main"/>
+          <a:p xmlns:a="http://schemas.openxmlformats.org/drawingml/2006/main">
+            <a:r>
+              <a:t>[Sources]</a:t>
+            </a:r>
+          </a:p>
+          <a:p xmlns:a="http://schemas.openxmlformats.org/drawingml/2006/main">
+            <a:r>
+              <a:t>- training/jays-book.json — deck title, sequence, and training framing.</a:t>
+            </a:r>
+          </a:p>
         </p:txBody>
       </p:sp>
       <p:sp>
@@ -510,7 +519,16 @@
         <p:txBody>
           <a:bodyPr xmlns:a="http://schemas.openxmlformats.org/drawingml/2006/main"/>
           <a:lstStyle xmlns:a="http://schemas.openxmlformats.org/drawingml/2006/main"/>
-          <a:p xmlns:a="http://schemas.openxmlformats.org/drawingml/2006/main"/>
+          <a:p xmlns:a="http://schemas.openxmlformats.org/drawingml/2006/main">
+            <a:r>
+              <a:t>[Sources]</a:t>
+            </a:r>
+          </a:p>
+          <a:p xmlns:a="http://schemas.openxmlformats.org/drawingml/2006/main">
+            <a:r>
+              <a:t>- docs/product/quickstart.md#connect-and-verify — single-sourced from Katie's maintained product documentation.</a:t>
+            </a:r>
+          </a:p>
         </p:txBody>
       </p:sp>
       <p:sp>
@@ -576,7 +594,16 @@
         <p:txBody>
           <a:bodyPr xmlns:a="http://schemas.openxmlformats.org/drawingml/2006/main"/>
           <a:lstStyle xmlns:a="http://schemas.openxmlformats.org/drawingml/2006/main"/>
-          <a:p xmlns:a="http://schemas.openxmlformats.org/drawingml/2006/main"/>
+          <a:p xmlns:a="http://schemas.openxmlformats.org/drawingml/2006/main">
+            <a:r>
+              <a:t>[Sources]</a:t>
+            </a:r>
+          </a:p>
+          <a:p xmlns:a="http://schemas.openxmlformats.org/drawingml/2006/main">
+            <a:r>
+              <a:t>- docs/product/operations.md#daily-check — single-sourced from Katie's maintained product documentation.</a:t>
+            </a:r>
+          </a:p>
         </p:txBody>
       </p:sp>
       <p:sp>
@@ -642,7 +669,16 @@
         <p:txBody>
           <a:bodyPr xmlns:a="http://schemas.openxmlformats.org/drawingml/2006/main"/>
           <a:lstStyle xmlns:a="http://schemas.openxmlformats.org/drawingml/2006/main"/>
-          <a:p xmlns:a="http://schemas.openxmlformats.org/drawingml/2006/main"/>
+          <a:p xmlns:a="http://schemas.openxmlformats.org/drawingml/2006/main">
+            <a:r>
+              <a:t>[Sources]</a:t>
+            </a:r>
+          </a:p>
+          <a:p xmlns:a="http://schemas.openxmlformats.org/drawingml/2006/main">
+            <a:r>
+              <a:t>- docs/product/architecture.md#decision-states — single-sourced from Katie's maintained product documentation.</a:t>
+            </a:r>
+          </a:p>
         </p:txBody>
       </p:sp>
       <p:sp>
@@ -708,7 +744,16 @@
         <p:txBody>
           <a:bodyPr xmlns:a="http://schemas.openxmlformats.org/drawingml/2006/main"/>
           <a:lstStyle xmlns:a="http://schemas.openxmlformats.org/drawingml/2006/main"/>
-          <a:p xmlns:a="http://schemas.openxmlformats.org/drawingml/2006/main"/>
+          <a:p xmlns:a="http://schemas.openxmlformats.org/drawingml/2006/main">
+            <a:r>
+              <a:t>[Sources]</a:t>
+            </a:r>
+          </a:p>
+          <a:p xmlns:a="http://schemas.openxmlformats.org/drawingml/2006/main">
+            <a:r>
+              <a:t>- training/jays-book.json — Jay's training-only exercise; not copied from Katie's maintained product documentation.</a:t>
+            </a:r>
+          </a:p>
         </p:txBody>
       </p:sp>
       <p:sp>
@@ -774,7 +819,7 @@
   </p:cSld>
   <p:clrMap bg1="lt1" tx1="dk1" bg2="lt2" tx2="dk2" accent1="accent1" accent2="accent2" accent3="accent3" accent4="accent4" accent5="accent5" accent6="accent6" hlink="hlink" folHlink="folHlink"/>
   <p:sldLayoutIdLst>
-    <p:sldLayoutId xmlns:r="http://schemas.openxmlformats.org/officeDocument/2006/relationships" id="2147483649" r:id="R7a05c59de9464ccf"/>
+    <p:sldLayoutId xmlns:r="http://schemas.openxmlformats.org/officeDocument/2006/relationships" id="2147483649" r:id="Ra24aef76942342ad"/>
   </p:sldLayoutIdLst>
   <p:txStyles>
     <p:titleStyle>
@@ -1325,7 +1370,7 @@
           <p:cNvPr id="4" name="eyebrow">
             <a:extLst xmlns:a="http://schemas.openxmlformats.org/drawingml/2006/main">
               <a:ext uri="{FF2B5EF4-FFF2-40B4-BE49-F238E27FC236}">
-                <a16:creationId xmlns:a16="http://schemas.microsoft.com/office/drawing/2014/main" id="{1386F666-08AD-46BA-B9C8-408B45348EEF}"/>
+                <a16:creationId xmlns:a16="http://schemas.microsoft.com/office/drawing/2014/main" id="{70884680-37E6-49F9-821E-BEB9A4BE11AD}"/>
               </a:ext>
             </a:extLst>
           </p:cNvPr>
@@ -1375,7 +1420,7 @@
           <p:cNvPr id="2" name="deck-title">
             <a:extLst xmlns:a="http://schemas.openxmlformats.org/drawingml/2006/main">
               <a:ext uri="{FF2B5EF4-FFF2-40B4-BE49-F238E27FC236}">
-                <a16:creationId xmlns:a16="http://schemas.microsoft.com/office/drawing/2014/main" id="{AAC8EAF8-8208-4D98-87EB-913623CD4D0F}"/>
+                <a16:creationId xmlns:a16="http://schemas.microsoft.com/office/drawing/2014/main" id="{03C5A291-CA7B-4820-967B-36B5A38B2F7F}"/>
               </a:ext>
             </a:extLst>
           </p:cNvPr>
@@ -1425,7 +1470,7 @@
           <p:cNvPr id="3" name="deck-subtitle">
             <a:extLst xmlns:a="http://schemas.openxmlformats.org/drawingml/2006/main">
               <a:ext uri="{FF2B5EF4-FFF2-40B4-BE49-F238E27FC236}">
-                <a16:creationId xmlns:a16="http://schemas.microsoft.com/office/drawing/2014/main" id="{2CC5A82C-998A-4CE0-9A5F-50BA5A0F2652}"/>
+                <a16:creationId xmlns:a16="http://schemas.microsoft.com/office/drawing/2014/main" id="{AF76D9F3-D887-4D94-AACB-1354E528980F}"/>
               </a:ext>
             </a:extLst>
           </p:cNvPr>
@@ -1473,7 +1518,7 @@
     </p:spTree>
     <p:extLst>
       <p:ext uri="{BB962C8B-B14F-4D97-AF65-F5344CB8AC3E}">
-        <p14:creationId xmlns:p14="http://schemas.microsoft.com/office/powerpoint/2010/main" val="1317715540"/>
+        <p14:creationId xmlns:p14="http://schemas.microsoft.com/office/powerpoint/2010/main" val="395833697"/>
       </p:ext>
     </p:extLst>
   </p:cSld>
@@ -1504,7 +1549,7 @@
           <p:cNvPr id="10" name="slide-2-title">
             <a:extLst xmlns:a="http://schemas.openxmlformats.org/drawingml/2006/main">
               <a:ext uri="{FF2B5EF4-FFF2-40B4-BE49-F238E27FC236}">
-                <a16:creationId xmlns:a16="http://schemas.microsoft.com/office/drawing/2014/main" id="{7B74D980-79EE-4413-A190-5FE8DA8A5274}"/>
+                <a16:creationId xmlns:a16="http://schemas.microsoft.com/office/drawing/2014/main" id="{E2A2C32F-B7B8-45D8-8333-3B33F297348C}"/>
               </a:ext>
             </a:extLst>
           </p:cNvPr>
@@ -1554,7 +1599,7 @@
           <p:cNvPr id="2" name="slide-2-rule">
             <a:extLst xmlns:a="http://schemas.openxmlformats.org/drawingml/2006/main">
               <a:ext uri="{FF2B5EF4-FFF2-40B4-BE49-F238E27FC236}">
-                <a16:creationId xmlns:a16="http://schemas.microsoft.com/office/drawing/2014/main" id="{61F36AA1-D695-48E1-894E-C999F2FB4419}"/>
+                <a16:creationId xmlns:a16="http://schemas.microsoft.com/office/drawing/2014/main" id="{BDCE2C50-D0AB-4FEF-93CD-EDB90E70D8EA}"/>
               </a:ext>
             </a:extLst>
           </p:cNvPr>
@@ -1585,7 +1630,7 @@
           <p:cNvPr id="3" name="slide-2-item-1">
             <a:extLst xmlns:a="http://schemas.openxmlformats.org/drawingml/2006/main">
               <a:ext uri="{FF2B5EF4-FFF2-40B4-BE49-F238E27FC236}">
-                <a16:creationId xmlns:a16="http://schemas.microsoft.com/office/drawing/2014/main" id="{159A0610-B26F-4F43-A49B-395A8BBD57B8}"/>
+                <a16:creationId xmlns:a16="http://schemas.microsoft.com/office/drawing/2014/main" id="{0360452C-2DB0-49ED-8718-1AA3AD000A17}"/>
               </a:ext>
             </a:extLst>
           </p:cNvPr>
@@ -1635,7 +1680,7 @@
           <p:cNvPr id="4" name="slide-2-item-2">
             <a:extLst xmlns:a="http://schemas.openxmlformats.org/drawingml/2006/main">
               <a:ext uri="{FF2B5EF4-FFF2-40B4-BE49-F238E27FC236}">
-                <a16:creationId xmlns:a16="http://schemas.microsoft.com/office/drawing/2014/main" id="{BFCCB62D-399B-4B42-97A4-A19D6D9B1CF8}"/>
+                <a16:creationId xmlns:a16="http://schemas.microsoft.com/office/drawing/2014/main" id="{8E4E9CD9-C49C-4D1B-BE46-BFC3EDA83522}"/>
               </a:ext>
             </a:extLst>
           </p:cNvPr>
@@ -1685,7 +1730,7 @@
           <p:cNvPr id="5" name="slide-2-item-3">
             <a:extLst xmlns:a="http://schemas.openxmlformats.org/drawingml/2006/main">
               <a:ext uri="{FF2B5EF4-FFF2-40B4-BE49-F238E27FC236}">
-                <a16:creationId xmlns:a16="http://schemas.microsoft.com/office/drawing/2014/main" id="{792E3E56-C8B8-47A4-B122-6E5FC51E8C67}"/>
+                <a16:creationId xmlns:a16="http://schemas.microsoft.com/office/drawing/2014/main" id="{02C4E24C-68EF-4F6C-BCEF-4D79B5F087EE}"/>
               </a:ext>
             </a:extLst>
           </p:cNvPr>
@@ -1735,7 +1780,7 @@
           <p:cNvPr id="6" name="slide-2-item-4">
             <a:extLst xmlns:a="http://schemas.openxmlformats.org/drawingml/2006/main">
               <a:ext uri="{FF2B5EF4-FFF2-40B4-BE49-F238E27FC236}">
-                <a16:creationId xmlns:a16="http://schemas.microsoft.com/office/drawing/2014/main" id="{A3B482F7-E7C9-4660-A65A-8DDBA8068B78}"/>
+                <a16:creationId xmlns:a16="http://schemas.microsoft.com/office/drawing/2014/main" id="{06357A40-68FB-43B1-A6E2-9619FEF23B55}"/>
               </a:ext>
             </a:extLst>
           </p:cNvPr>
@@ -1785,7 +1830,7 @@
           <p:cNvPr id="7" name="slide-2-item-5">
             <a:extLst xmlns:a="http://schemas.openxmlformats.org/drawingml/2006/main">
               <a:ext uri="{FF2B5EF4-FFF2-40B4-BE49-F238E27FC236}">
-                <a16:creationId xmlns:a16="http://schemas.microsoft.com/office/drawing/2014/main" id="{ECCCBCEF-0307-4F6B-AB38-5EF385FC8EE5}"/>
+                <a16:creationId xmlns:a16="http://schemas.microsoft.com/office/drawing/2014/main" id="{9B08A308-2BBD-419A-AC5A-CAC65A200806}"/>
               </a:ext>
             </a:extLst>
           </p:cNvPr>
@@ -1835,7 +1880,7 @@
           <p:cNvPr id="8" name="slide-2-item-6">
             <a:extLst xmlns:a="http://schemas.openxmlformats.org/drawingml/2006/main">
               <a:ext uri="{FF2B5EF4-FFF2-40B4-BE49-F238E27FC236}">
-                <a16:creationId xmlns:a16="http://schemas.microsoft.com/office/drawing/2014/main" id="{65FF5E95-CFE7-4FAC-85C1-B7B5073C8015}"/>
+                <a16:creationId xmlns:a16="http://schemas.microsoft.com/office/drawing/2014/main" id="{84826B9B-0A9D-4675-869F-086C60461C00}"/>
               </a:ext>
             </a:extLst>
           </p:cNvPr>
@@ -1885,7 +1930,7 @@
           <p:cNvPr id="9" name="slide-2-footer">
             <a:extLst xmlns:a="http://schemas.openxmlformats.org/drawingml/2006/main">
               <a:ext uri="{FF2B5EF4-FFF2-40B4-BE49-F238E27FC236}">
-                <a16:creationId xmlns:a16="http://schemas.microsoft.com/office/drawing/2014/main" id="{FEF8F254-D66D-4643-AE2B-FCF833BCC613}"/>
+                <a16:creationId xmlns:a16="http://schemas.microsoft.com/office/drawing/2014/main" id="{C8008178-E9B3-4585-B4B6-02AF78823913}"/>
               </a:ext>
             </a:extLst>
           </p:cNvPr>
@@ -1933,7 +1978,7 @@
     </p:spTree>
     <p:extLst>
       <p:ext uri="{BB962C8B-B14F-4D97-AF65-F5344CB8AC3E}">
-        <p14:creationId xmlns:p14="http://schemas.microsoft.com/office/powerpoint/2010/main" val="445229122"/>
+        <p14:creationId xmlns:p14="http://schemas.microsoft.com/office/powerpoint/2010/main" val="1124520023"/>
       </p:ext>
     </p:extLst>
   </p:cSld>
@@ -1964,7 +2009,7 @@
           <p:cNvPr id="9" name="slide-3-title">
             <a:extLst xmlns:a="http://schemas.openxmlformats.org/drawingml/2006/main">
               <a:ext uri="{FF2B5EF4-FFF2-40B4-BE49-F238E27FC236}">
-                <a16:creationId xmlns:a16="http://schemas.microsoft.com/office/drawing/2014/main" id="{8D5462A6-964D-447C-B1BB-C4AD5AA84B49}"/>
+                <a16:creationId xmlns:a16="http://schemas.microsoft.com/office/drawing/2014/main" id="{9BE35538-3772-4249-B596-81E1C985B24C}"/>
               </a:ext>
             </a:extLst>
           </p:cNvPr>
@@ -2014,7 +2059,7 @@
           <p:cNvPr id="2" name="slide-3-rule">
             <a:extLst xmlns:a="http://schemas.openxmlformats.org/drawingml/2006/main">
               <a:ext uri="{FF2B5EF4-FFF2-40B4-BE49-F238E27FC236}">
-                <a16:creationId xmlns:a16="http://schemas.microsoft.com/office/drawing/2014/main" id="{2B4570DB-5F2E-4D55-AF59-0A305AC7A51A}"/>
+                <a16:creationId xmlns:a16="http://schemas.microsoft.com/office/drawing/2014/main" id="{45614460-E4A2-46E7-A816-A6723AEE186C}"/>
               </a:ext>
             </a:extLst>
           </p:cNvPr>
@@ -2045,7 +2090,7 @@
           <p:cNvPr id="3" name="slide-3-item-1">
             <a:extLst xmlns:a="http://schemas.openxmlformats.org/drawingml/2006/main">
               <a:ext uri="{FF2B5EF4-FFF2-40B4-BE49-F238E27FC236}">
-                <a16:creationId xmlns:a16="http://schemas.microsoft.com/office/drawing/2014/main" id="{768FDB91-60CC-4509-B6BD-0FB831A252EC}"/>
+                <a16:creationId xmlns:a16="http://schemas.microsoft.com/office/drawing/2014/main" id="{30A259F6-4816-4DDD-AEA1-D942E917A818}"/>
               </a:ext>
             </a:extLst>
           </p:cNvPr>
@@ -2095,7 +2140,7 @@
           <p:cNvPr id="4" name="slide-3-item-2">
             <a:extLst xmlns:a="http://schemas.openxmlformats.org/drawingml/2006/main">
               <a:ext uri="{FF2B5EF4-FFF2-40B4-BE49-F238E27FC236}">
-                <a16:creationId xmlns:a16="http://schemas.microsoft.com/office/drawing/2014/main" id="{74C5DFEF-9380-4D72-8F15-3259F79D1E30}"/>
+                <a16:creationId xmlns:a16="http://schemas.microsoft.com/office/drawing/2014/main" id="{2F6FA6F0-F946-4103-9F58-9D7BB110DD51}"/>
               </a:ext>
             </a:extLst>
           </p:cNvPr>
@@ -2145,7 +2190,7 @@
           <p:cNvPr id="5" name="slide-3-item-3">
             <a:extLst xmlns:a="http://schemas.openxmlformats.org/drawingml/2006/main">
               <a:ext uri="{FF2B5EF4-FFF2-40B4-BE49-F238E27FC236}">
-                <a16:creationId xmlns:a16="http://schemas.microsoft.com/office/drawing/2014/main" id="{16A82823-B5F4-4450-BC15-8D13918FEE9D}"/>
+                <a16:creationId xmlns:a16="http://schemas.microsoft.com/office/drawing/2014/main" id="{AB7B20B4-B12A-49A3-ADCB-65457266C869}"/>
               </a:ext>
             </a:extLst>
           </p:cNvPr>
@@ -2195,7 +2240,7 @@
           <p:cNvPr id="6" name="slide-3-item-4">
             <a:extLst xmlns:a="http://schemas.openxmlformats.org/drawingml/2006/main">
               <a:ext uri="{FF2B5EF4-FFF2-40B4-BE49-F238E27FC236}">
-                <a16:creationId xmlns:a16="http://schemas.microsoft.com/office/drawing/2014/main" id="{BB4D8238-3D63-4A2E-A484-209BF4E219AD}"/>
+                <a16:creationId xmlns:a16="http://schemas.microsoft.com/office/drawing/2014/main" id="{FD07B7B6-4686-4460-8D4E-FB777EA7B239}"/>
               </a:ext>
             </a:extLst>
           </p:cNvPr>
@@ -2245,7 +2290,7 @@
           <p:cNvPr id="7" name="slide-3-item-5">
             <a:extLst xmlns:a="http://schemas.openxmlformats.org/drawingml/2006/main">
               <a:ext uri="{FF2B5EF4-FFF2-40B4-BE49-F238E27FC236}">
-                <a16:creationId xmlns:a16="http://schemas.microsoft.com/office/drawing/2014/main" id="{C166386E-C674-4838-BD08-83D9804BC9C8}"/>
+                <a16:creationId xmlns:a16="http://schemas.microsoft.com/office/drawing/2014/main" id="{436D55F3-F561-4F08-AA9B-19A94058AE86}"/>
               </a:ext>
             </a:extLst>
           </p:cNvPr>
@@ -2295,7 +2340,7 @@
           <p:cNvPr id="8" name="slide-3-footer">
             <a:extLst xmlns:a="http://schemas.openxmlformats.org/drawingml/2006/main">
               <a:ext uri="{FF2B5EF4-FFF2-40B4-BE49-F238E27FC236}">
-                <a16:creationId xmlns:a16="http://schemas.microsoft.com/office/drawing/2014/main" id="{987A7A7D-6358-437F-8C8E-EA73809CFB93}"/>
+                <a16:creationId xmlns:a16="http://schemas.microsoft.com/office/drawing/2014/main" id="{240B6794-D10E-4E11-AA43-30C63755DF7D}"/>
               </a:ext>
             </a:extLst>
           </p:cNvPr>
@@ -2343,7 +2388,7 @@
     </p:spTree>
     <p:extLst>
       <p:ext uri="{BB962C8B-B14F-4D97-AF65-F5344CB8AC3E}">
-        <p14:creationId xmlns:p14="http://schemas.microsoft.com/office/powerpoint/2010/main" val="400950151"/>
+        <p14:creationId xmlns:p14="http://schemas.microsoft.com/office/powerpoint/2010/main" val="1172898338"/>
       </p:ext>
     </p:extLst>
   </p:cSld>
@@ -2374,7 +2419,7 @@
           <p:cNvPr id="10" name="slide-4-title">
             <a:extLst xmlns:a="http://schemas.openxmlformats.org/drawingml/2006/main">
               <a:ext uri="{FF2B5EF4-FFF2-40B4-BE49-F238E27FC236}">
-                <a16:creationId xmlns:a16="http://schemas.microsoft.com/office/drawing/2014/main" id="{CC02F5D5-F444-40CF-B970-216CB495273B}"/>
+                <a16:creationId xmlns:a16="http://schemas.microsoft.com/office/drawing/2014/main" id="{45BB9C94-E7DE-4AD4-A90F-1866A8AF401A}"/>
               </a:ext>
             </a:extLst>
           </p:cNvPr>
@@ -2424,7 +2469,7 @@
           <p:cNvPr id="2" name="slide-4-rule">
             <a:extLst xmlns:a="http://schemas.openxmlformats.org/drawingml/2006/main">
               <a:ext uri="{FF2B5EF4-FFF2-40B4-BE49-F238E27FC236}">
-                <a16:creationId xmlns:a16="http://schemas.microsoft.com/office/drawing/2014/main" id="{3FD80E3E-CCEF-4E9D-AAF6-A1CB85DD7FAA}"/>
+                <a16:creationId xmlns:a16="http://schemas.microsoft.com/office/drawing/2014/main" id="{7DE1364E-1892-42DB-A0B5-E19803E91E6E}"/>
               </a:ext>
             </a:extLst>
           </p:cNvPr>
@@ -2455,7 +2500,7 @@
           <p:cNvPr id="3" name="slide-4-item-1">
             <a:extLst xmlns:a="http://schemas.openxmlformats.org/drawingml/2006/main">
               <a:ext uri="{FF2B5EF4-FFF2-40B4-BE49-F238E27FC236}">
-                <a16:creationId xmlns:a16="http://schemas.microsoft.com/office/drawing/2014/main" id="{1A6E90CF-8FE8-4690-8894-F3AE36EC3F42}"/>
+                <a16:creationId xmlns:a16="http://schemas.microsoft.com/office/drawing/2014/main" id="{B4973233-A950-417D-8EB1-08CC473B0C4F}"/>
               </a:ext>
             </a:extLst>
           </p:cNvPr>
@@ -2505,7 +2550,7 @@
           <p:cNvPr id="4" name="slide-4-item-2">
             <a:extLst xmlns:a="http://schemas.openxmlformats.org/drawingml/2006/main">
               <a:ext uri="{FF2B5EF4-FFF2-40B4-BE49-F238E27FC236}">
-                <a16:creationId xmlns:a16="http://schemas.microsoft.com/office/drawing/2014/main" id="{2E1AD7C5-5BAA-48FB-B667-1E2ADF603525}"/>
+                <a16:creationId xmlns:a16="http://schemas.microsoft.com/office/drawing/2014/main" id="{9534A9E9-2919-4E74-9751-A46B5204AC95}"/>
               </a:ext>
             </a:extLst>
           </p:cNvPr>
@@ -2555,7 +2600,7 @@
           <p:cNvPr id="5" name="slide-4-item-3">
             <a:extLst xmlns:a="http://schemas.openxmlformats.org/drawingml/2006/main">
               <a:ext uri="{FF2B5EF4-FFF2-40B4-BE49-F238E27FC236}">
-                <a16:creationId xmlns:a16="http://schemas.microsoft.com/office/drawing/2014/main" id="{62331C5D-E131-4BFF-B50A-0427983AD305}"/>
+                <a16:creationId xmlns:a16="http://schemas.microsoft.com/office/drawing/2014/main" id="{D190EA01-C10A-4135-BF38-809083CD11B4}"/>
               </a:ext>
             </a:extLst>
           </p:cNvPr>
@@ -2605,7 +2650,7 @@
           <p:cNvPr id="6" name="slide-4-item-4">
             <a:extLst xmlns:a="http://schemas.openxmlformats.org/drawingml/2006/main">
               <a:ext uri="{FF2B5EF4-FFF2-40B4-BE49-F238E27FC236}">
-                <a16:creationId xmlns:a16="http://schemas.microsoft.com/office/drawing/2014/main" id="{07E59B4F-9A6C-4E5C-BB07-5710E2C1CBDB}"/>
+                <a16:creationId xmlns:a16="http://schemas.microsoft.com/office/drawing/2014/main" id="{AD031A42-D9BF-42C0-8427-6D273219AEEF}"/>
               </a:ext>
             </a:extLst>
           </p:cNvPr>
@@ -2655,7 +2700,7 @@
           <p:cNvPr id="7" name="slide-4-item-5">
             <a:extLst xmlns:a="http://schemas.openxmlformats.org/drawingml/2006/main">
               <a:ext uri="{FF2B5EF4-FFF2-40B4-BE49-F238E27FC236}">
-                <a16:creationId xmlns:a16="http://schemas.microsoft.com/office/drawing/2014/main" id="{D1FAB542-D43B-44AE-8ADB-C244BB8D81DE}"/>
+                <a16:creationId xmlns:a16="http://schemas.microsoft.com/office/drawing/2014/main" id="{6E9D1688-B0BF-44E0-8968-7339C9E4FBB8}"/>
               </a:ext>
             </a:extLst>
           </p:cNvPr>
@@ -2705,7 +2750,7 @@
           <p:cNvPr id="8" name="slide-4-item-6">
             <a:extLst xmlns:a="http://schemas.openxmlformats.org/drawingml/2006/main">
               <a:ext uri="{FF2B5EF4-FFF2-40B4-BE49-F238E27FC236}">
-                <a16:creationId xmlns:a16="http://schemas.microsoft.com/office/drawing/2014/main" id="{417C72C6-7F83-4034-BCA2-CDF94B474965}"/>
+                <a16:creationId xmlns:a16="http://schemas.microsoft.com/office/drawing/2014/main" id="{D4A117CA-BC9B-44F7-B82F-DCAEF0F84CEB}"/>
               </a:ext>
             </a:extLst>
           </p:cNvPr>
@@ -2755,7 +2800,7 @@
           <p:cNvPr id="9" name="slide-4-footer">
             <a:extLst xmlns:a="http://schemas.openxmlformats.org/drawingml/2006/main">
               <a:ext uri="{FF2B5EF4-FFF2-40B4-BE49-F238E27FC236}">
-                <a16:creationId xmlns:a16="http://schemas.microsoft.com/office/drawing/2014/main" id="{7818D630-8FC9-48D4-A057-06002009F626}"/>
+                <a16:creationId xmlns:a16="http://schemas.microsoft.com/office/drawing/2014/main" id="{2E96FEBE-A25F-4BF3-BA41-16362395ABCD}"/>
               </a:ext>
             </a:extLst>
           </p:cNvPr>
@@ -2803,7 +2848,7 @@
     </p:spTree>
     <p:extLst>
       <p:ext uri="{BB962C8B-B14F-4D97-AF65-F5344CB8AC3E}">
-        <p14:creationId xmlns:p14="http://schemas.microsoft.com/office/powerpoint/2010/main" val="751871043"/>
+        <p14:creationId xmlns:p14="http://schemas.microsoft.com/office/powerpoint/2010/main" val="1388756135"/>
       </p:ext>
     </p:extLst>
   </p:cSld>
@@ -2834,7 +2879,7 @@
           <p:cNvPr id="7" name="slide-5-title">
             <a:extLst xmlns:a="http://schemas.openxmlformats.org/drawingml/2006/main">
               <a:ext uri="{FF2B5EF4-FFF2-40B4-BE49-F238E27FC236}">
-                <a16:creationId xmlns:a16="http://schemas.microsoft.com/office/drawing/2014/main" id="{633BA15F-FBDF-4793-82EB-6CA790E153D7}"/>
+                <a16:creationId xmlns:a16="http://schemas.microsoft.com/office/drawing/2014/main" id="{B74A3FF2-3D1A-4825-89AF-4F0296C30EBC}"/>
               </a:ext>
             </a:extLst>
           </p:cNvPr>
@@ -2884,7 +2929,7 @@
           <p:cNvPr id="2" name="slide-5-rule">
             <a:extLst xmlns:a="http://schemas.openxmlformats.org/drawingml/2006/main">
               <a:ext uri="{FF2B5EF4-FFF2-40B4-BE49-F238E27FC236}">
-                <a16:creationId xmlns:a16="http://schemas.microsoft.com/office/drawing/2014/main" id="{6677D35B-90A8-470F-8767-129F773D5818}"/>
+                <a16:creationId xmlns:a16="http://schemas.microsoft.com/office/drawing/2014/main" id="{B902D861-C07C-437C-BCDD-5E4370D989D6}"/>
               </a:ext>
             </a:extLst>
           </p:cNvPr>
@@ -2915,7 +2960,7 @@
           <p:cNvPr id="3" name="slide-5-item-1">
             <a:extLst xmlns:a="http://schemas.openxmlformats.org/drawingml/2006/main">
               <a:ext uri="{FF2B5EF4-FFF2-40B4-BE49-F238E27FC236}">
-                <a16:creationId xmlns:a16="http://schemas.microsoft.com/office/drawing/2014/main" id="{0600FE27-72B2-433A-9D06-12CD8D789787}"/>
+                <a16:creationId xmlns:a16="http://schemas.microsoft.com/office/drawing/2014/main" id="{78839901-8431-4336-8E6B-67888B75EED7}"/>
               </a:ext>
             </a:extLst>
           </p:cNvPr>
@@ -2965,7 +3010,7 @@
           <p:cNvPr id="4" name="slide-5-item-2">
             <a:extLst xmlns:a="http://schemas.openxmlformats.org/drawingml/2006/main">
               <a:ext uri="{FF2B5EF4-FFF2-40B4-BE49-F238E27FC236}">
-                <a16:creationId xmlns:a16="http://schemas.microsoft.com/office/drawing/2014/main" id="{06191358-AB7C-464A-86C7-89A06EB9C381}"/>
+                <a16:creationId xmlns:a16="http://schemas.microsoft.com/office/drawing/2014/main" id="{D3F42FC7-15ED-4EFD-A893-D674E4DBF6C1}"/>
               </a:ext>
             </a:extLst>
           </p:cNvPr>
@@ -3015,7 +3060,7 @@
           <p:cNvPr id="5" name="slide-5-item-3">
             <a:extLst xmlns:a="http://schemas.openxmlformats.org/drawingml/2006/main">
               <a:ext uri="{FF2B5EF4-FFF2-40B4-BE49-F238E27FC236}">
-                <a16:creationId xmlns:a16="http://schemas.microsoft.com/office/drawing/2014/main" id="{E7CDF6D7-0080-4A7A-AF58-2AA5F66ED0A5}"/>
+                <a16:creationId xmlns:a16="http://schemas.microsoft.com/office/drawing/2014/main" id="{3F347672-2EC5-4698-B61C-ADB38F39A289}"/>
               </a:ext>
             </a:extLst>
           </p:cNvPr>
@@ -3065,7 +3110,7 @@
           <p:cNvPr id="6" name="slide-5-footer">
             <a:extLst xmlns:a="http://schemas.openxmlformats.org/drawingml/2006/main">
               <a:ext uri="{FF2B5EF4-FFF2-40B4-BE49-F238E27FC236}">
-                <a16:creationId xmlns:a16="http://schemas.microsoft.com/office/drawing/2014/main" id="{22DD38DD-59C1-4882-9D0B-090413F2C900}"/>
+                <a16:creationId xmlns:a16="http://schemas.microsoft.com/office/drawing/2014/main" id="{F18C1794-893E-4A8F-B1CA-F62D7D144BC8}"/>
               </a:ext>
             </a:extLst>
           </p:cNvPr>
@@ -3113,7 +3158,7 @@
     </p:spTree>
     <p:extLst>
       <p:ext uri="{BB962C8B-B14F-4D97-AF65-F5344CB8AC3E}">
-        <p14:creationId xmlns:p14="http://schemas.microsoft.com/office/powerpoint/2010/main" val="526937416"/>
+        <p14:creationId xmlns:p14="http://schemas.microsoft.com/office/powerpoint/2010/main" val="462300185"/>
       </p:ext>
     </p:extLst>
   </p:cSld>

</xml_diff>